<commit_message>
S01 v6: libreria Higgsfield, fondos unicos oscuro/claro
</commit_message>
<xml_diff>
--- a/Domingo-14/S01_Domingo-14_2_Post_Cuenta-tu-caso_1x1.pptx
+++ b/Domingo-14/S01_Domingo-14_2_Post_Cuenta-tu-caso_1x1.pptx
@@ -3098,7 +3098,7 @@
       <p:grpSpPr/>
       <p:pic>
         <p:nvPicPr>
-          <p:cNvPr id="2" name="Picture 1" descr="negocio.png"/>
+          <p:cNvPr id="2" name="Picture 1" descr="balanza.png"/>
           <p:cNvPicPr>
             <a:picLocks noChangeAspect="1"/>
           </p:cNvPicPr>
@@ -3112,8 +3112,8 @@
         </p:blipFill>
         <p:spPr>
           <a:xfrm>
-            <a:off x="0" y="-3257550"/>
-            <a:ext cx="8229600" cy="14744700"/>
+            <a:off x="0" y="-993227"/>
+            <a:ext cx="8229600" cy="10216055"/>
           </a:xfrm>
           <a:prstGeom prst="rect">
             <a:avLst/>

</xml_diff>